<commit_message>
docs(project): demo is a video linked in the report; live Q&A only for flagged teams (#157)
Owner decision 2026-10-24: the MFU final day (Session 7, Sat 14 Nov) already
holds the written exam (AM) and the capstone CTF (PM), so there is no per-team
3-minute Q&A slot any more.

- The demo is a recorded video walkthrough, shared as an unlisted YouTube or
  Google Drive link in the report (new row in the REPORT-TEMPLATE cover table)
  and due with the report; graded asynchronously on the project rubric.
- The instructor may call any team (e.g. report != repo, similarity hit) for a
  short live Q&A: a viva spot-check, not a re-demo.
- Updated consistently: project/README.md, REPORT-TEMPLATE.md, SUBMISSION.md,
  syllabus-mfu.md (video due Fri 6 Nov 16:59), syllabus.md, course-plan,
  AGENDA.md (decision note), Week 16/19 lab READMEs + worksheet note, Week 19
  capstone-map.svg, slides week17/week19 (+ pptx), lesson plans week17/18/19.

Co-authored-by: Claude Opus 5.5 <noreply@anthropic.com>
</commit_message>
<xml_diff>
--- a/slides/pptx/week17.pptx
+++ b/slides/pptx/week17.pptx
@@ -1501,7 +1501,7 @@
       </p:grpSpPr>
       <p:pic>
         <p:nvPicPr>
-          <p:cNvPr id="2" name="Image 0" descr="/private/tmp/claude-501/-Users-pop7-Library-CloudStorage-OneDrive-MonsterConnectCo--Ltd-Lecture-KOSEN69---software-security/e6d6556f-17de-403d-a9a0-cf2f846149b4/scratchpad/tree/slides/pptx/assets/logo-small.png">    </p:cNvPr>
+          <p:cNvPr id="2" name="Image 0" descr="/private/tmp/claude-501/-Users-pop7-Library-CloudStorage-OneDrive-MonsterConnectCo--Ltd-Lecture-KOSEN69---software-security/f63a82af-e1ad-40ed-89c4-03c6ca776e3f/scratchpad/lq-docs/slides/pptx/assets/logo-small.png">    </p:cNvPr>
           <p:cNvPicPr>
             <a:picLocks noChangeAspect="1"/>
           </p:cNvPicPr>
@@ -1922,7 +1922,7 @@
       </p:sp>
       <p:pic>
         <p:nvPicPr>
-          <p:cNvPr id="8" name="Image 1" descr="/private/tmp/claude-501/-Users-pop7-Library-CloudStorage-OneDrive-MonsterConnectCo--Ltd-Lecture-KOSEN69---software-security/e6d6556f-17de-403d-a9a0-cf2f846149b4/scratchpad/tree/slides/pptx/assets/logo-small.png">    </p:cNvPr>
+          <p:cNvPr id="8" name="Image 1" descr="/private/tmp/claude-501/-Users-pop7-Library-CloudStorage-OneDrive-MonsterConnectCo--Ltd-Lecture-KOSEN69---software-security/f63a82af-e1ad-40ed-89c4-03c6ca776e3f/scratchpad/lq-docs/slides/pptx/assets/logo-small.png">    </p:cNvPr>
           <p:cNvPicPr>
             <a:picLocks noChangeAspect="1"/>
           </p:cNvPicPr>
@@ -2131,7 +2131,7 @@
       </p:sp>
       <p:pic>
         <p:nvPicPr>
-          <p:cNvPr id="7" name="Image 2" descr="/private/tmp/claude-501/-Users-pop7-Library-CloudStorage-OneDrive-MonsterConnectCo--Ltd-Lecture-KOSEN69---software-security/e6d6556f-17de-403d-a9a0-cf2f846149b4/scratchpad/tree/slides/pptx/assets/logo-small.png">    </p:cNvPr>
+          <p:cNvPr id="7" name="Image 2" descr="/private/tmp/claude-501/-Users-pop7-Library-CloudStorage-OneDrive-MonsterConnectCo--Ltd-Lecture-KOSEN69---software-security/f63a82af-e1ad-40ed-89c4-03c6ca776e3f/scratchpad/lq-docs/slides/pptx/assets/logo-small.png">    </p:cNvPr>
           <p:cNvPicPr>
             <a:picLocks noChangeAspect="1"/>
           </p:cNvPicPr>
@@ -2759,7 +2759,7 @@
       </p:sp>
       <p:pic>
         <p:nvPicPr>
-          <p:cNvPr id="8" name="Image 1" descr="/private/tmp/claude-501/-Users-pop7-Library-CloudStorage-OneDrive-MonsterConnectCo--Ltd-Lecture-KOSEN69---software-security/e6d6556f-17de-403d-a9a0-cf2f846149b4/scratchpad/tree/slides/pptx/assets/logo-small.png">    </p:cNvPr>
+          <p:cNvPr id="8" name="Image 1" descr="/private/tmp/claude-501/-Users-pop7-Library-CloudStorage-OneDrive-MonsterConnectCo--Ltd-Lecture-KOSEN69---software-security/f63a82af-e1ad-40ed-89c4-03c6ca776e3f/scratchpad/lq-docs/slides/pptx/assets/logo-small.png">    </p:cNvPr>
           <p:cNvPicPr>
             <a:picLocks noChangeAspect="1"/>
           </p:cNvPicPr>
@@ -3101,7 +3101,7 @@
       </p:sp>
       <p:pic>
         <p:nvPicPr>
-          <p:cNvPr id="9" name="Image 1" descr="/private/tmp/claude-501/-Users-pop7-Library-CloudStorage-OneDrive-MonsterConnectCo--Ltd-Lecture-KOSEN69---software-security/e6d6556f-17de-403d-a9a0-cf2f846149b4/scratchpad/tree/slides/pptx/assets/logo-small.png">    </p:cNvPr>
+          <p:cNvPr id="9" name="Image 1" descr="/private/tmp/claude-501/-Users-pop7-Library-CloudStorage-OneDrive-MonsterConnectCo--Ltd-Lecture-KOSEN69---software-security/f63a82af-e1ad-40ed-89c4-03c6ca776e3f/scratchpad/lq-docs/slides/pptx/assets/logo-small.png">    </p:cNvPr>
           <p:cNvPicPr>
             <a:picLocks noChangeAspect="1"/>
           </p:cNvPicPr>
@@ -3360,7 +3360,7 @@
       </p:sp>
       <p:pic>
         <p:nvPicPr>
-          <p:cNvPr id="8" name="Image 1" descr="/private/tmp/claude-501/-Users-pop7-Library-CloudStorage-OneDrive-MonsterConnectCo--Ltd-Lecture-KOSEN69---software-security/e6d6556f-17de-403d-a9a0-cf2f846149b4/scratchpad/tree/slides/pptx/assets/logo-small.png">    </p:cNvPr>
+          <p:cNvPr id="8" name="Image 1" descr="/private/tmp/claude-501/-Users-pop7-Library-CloudStorage-OneDrive-MonsterConnectCo--Ltd-Lecture-KOSEN69---software-security/f63a82af-e1ad-40ed-89c4-03c6ca776e3f/scratchpad/lq-docs/slides/pptx/assets/logo-small.png">    </p:cNvPr>
           <p:cNvPicPr>
             <a:picLocks noChangeAspect="1"/>
           </p:cNvPicPr>
@@ -3593,7 +3593,7 @@
                 <a:ea typeface="Calibri" pitchFamily="34" charset="-122"/>
                 <a:cs typeface="Calibri" pitchFamily="34" charset="-120"/>
               </a:rPr>
-              <a:t>Wk 19: capstone CTF tournament + final project demos (video walkthrough submitted before the session + a short live Q&amp;A — not a live demo slot)</a:t>
+              <a:t>Wk 19: capstone CTF tournament + final project demos (video walkthrough linked in the report, due with it; live Q&amp;A only if the instructor calls your team)</a:t>
             </a:r>
             <a:endParaRPr lang="en-US" sz="1400" dirty="0"/>
           </a:p>
@@ -3640,7 +3640,7 @@
       </p:sp>
       <p:pic>
         <p:nvPicPr>
-          <p:cNvPr id="8" name="Image 1" descr="/private/tmp/claude-501/-Users-pop7-Library-CloudStorage-OneDrive-MonsterConnectCo--Ltd-Lecture-KOSEN69---software-security/e6d6556f-17de-403d-a9a0-cf2f846149b4/scratchpad/tree/slides/pptx/assets/logo-small.png">    </p:cNvPr>
+          <p:cNvPr id="8" name="Image 1" descr="/private/tmp/claude-501/-Users-pop7-Library-CloudStorage-OneDrive-MonsterConnectCo--Ltd-Lecture-KOSEN69---software-security/f63a82af-e1ad-40ed-89c4-03c6ca776e3f/scratchpad/lq-docs/slides/pptx/assets/logo-small.png">    </p:cNvPr>
           <p:cNvPicPr>
             <a:picLocks noChangeAspect="1"/>
           </p:cNvPicPr>
@@ -3774,7 +3774,7 @@
       </p:sp>
       <p:pic>
         <p:nvPicPr>
-          <p:cNvPr id="4" name="Image 0" descr="/private/tmp/claude-501/-Users-pop7-Library-CloudStorage-OneDrive-MonsterConnectCo--Ltd-Lecture-KOSEN69---software-security/e6d6556f-17de-403d-a9a0-cf2f846149b4/scratchpad/tree/slides/pptx/assets/logo-small.png">    </p:cNvPr>
+          <p:cNvPr id="4" name="Image 0" descr="/private/tmp/claude-501/-Users-pop7-Library-CloudStorage-OneDrive-MonsterConnectCo--Ltd-Lecture-KOSEN69---software-security/f63a82af-e1ad-40ed-89c4-03c6ca776e3f/scratchpad/lq-docs/slides/pptx/assets/logo-small.png">    </p:cNvPr>
           <p:cNvPicPr>
             <a:picLocks noChangeAspect="1"/>
           </p:cNvPicPr>

</xml_diff>